<commit_message>
Adicionando os slides do Guilherme
</commit_message>
<xml_diff>
--- a/Slide_labirinto.pptx
+++ b/Slide_labirinto.pptx
@@ -5,17 +5,30 @@
     <p:sldMasterId id="2147483666" r:id="rId1"/>
   </p:sldMasterIdLst>
   <p:notesMasterIdLst>
-    <p:notesMasterId r:id="rId7"/>
+    <p:notesMasterId r:id="rId11"/>
   </p:notesMasterIdLst>
   <p:sldIdLst>
     <p:sldId id="256" r:id="rId2"/>
     <p:sldId id="257" r:id="rId3"/>
     <p:sldId id="258" r:id="rId4"/>
     <p:sldId id="261" r:id="rId5"/>
-    <p:sldId id="259" r:id="rId6"/>
+    <p:sldId id="260" r:id="rId6"/>
+    <p:sldId id="262" r:id="rId7"/>
+    <p:sldId id="263" r:id="rId8"/>
+    <p:sldId id="264" r:id="rId9"/>
+    <p:sldId id="259" r:id="rId10"/>
   </p:sldIdLst>
   <p:sldSz cx="9144000" cy="5143500" type="screen16x9"/>
   <p:notesSz cx="6858000" cy="9144000"/>
+  <p:embeddedFontLst>
+    <p:embeddedFont>
+      <p:font typeface="Albert Sans" panose="020B0604020202020204" charset="0"/>
+      <p:regular r:id="rId12"/>
+      <p:bold r:id="rId13"/>
+      <p:italic r:id="rId14"/>
+      <p:boldItalic r:id="rId15"/>
+    </p:embeddedFont>
+  </p:embeddedFontLst>
   <p:defaultTextStyle>
     <a:defPPr marR="0" lvl="0" algn="l" rtl="0">
       <a:lnSpc>
@@ -1106,7 +1119,7 @@
         </p:nvSpPr>
         <p:spPr>
           <a:xfrm>
-            <a:off x="381300" y="685800"/>
+            <a:off x="381000" y="685800"/>
             <a:ext cx="6096000" cy="3429000"/>
           </a:xfrm>
           <a:custGeom>
@@ -1200,6 +1213,514 @@
 </file>
 
 <file path=ppt/notesSlides/notesSlide4.xml><?xml version="1.0" encoding="utf-8"?>
+<p:notes xmlns:a="http://schemas.openxmlformats.org/drawingml/2006/main" xmlns:r="http://schemas.openxmlformats.org/officeDocument/2006/relationships" xmlns:p="http://schemas.openxmlformats.org/presentationml/2006/main" showMasterSp="0" showMasterPhAnim="0">
+  <p:cSld>
+    <p:spTree>
+      <p:nvGrpSpPr>
+        <p:cNvPr id="1" name="Shape 88"/>
+        <p:cNvGrpSpPr/>
+        <p:nvPr/>
+      </p:nvGrpSpPr>
+      <p:grpSpPr>
+        <a:xfrm>
+          <a:off x="0" y="0"/>
+          <a:ext cx="0" cy="0"/>
+          <a:chOff x="0" y="0"/>
+          <a:chExt cx="0" cy="0"/>
+        </a:xfrm>
+      </p:grpSpPr>
+      <p:sp>
+        <p:nvSpPr>
+          <p:cNvPr id="89" name="Google Shape;89;p3:notes"/>
+          <p:cNvSpPr>
+            <a:spLocks noGrp="1" noRot="1" noChangeAspect="1"/>
+          </p:cNvSpPr>
+          <p:nvPr>
+            <p:ph type="sldImg" idx="2"/>
+          </p:nvPr>
+        </p:nvSpPr>
+        <p:spPr>
+          <a:xfrm>
+            <a:off x="381000" y="685800"/>
+            <a:ext cx="6096000" cy="3429000"/>
+          </a:xfrm>
+          <a:custGeom>
+            <a:avLst/>
+            <a:gdLst/>
+            <a:ahLst/>
+            <a:cxnLst/>
+            <a:rect l="l" t="t" r="r" b="b"/>
+            <a:pathLst>
+              <a:path w="120000" h="120000" extrusionOk="0">
+                <a:moveTo>
+                  <a:pt x="0" y="0"/>
+                </a:moveTo>
+                <a:lnTo>
+                  <a:pt x="120000" y="0"/>
+                </a:lnTo>
+                <a:lnTo>
+                  <a:pt x="120000" y="120000"/>
+                </a:lnTo>
+                <a:lnTo>
+                  <a:pt x="0" y="120000"/>
+                </a:lnTo>
+                <a:close/>
+              </a:path>
+            </a:pathLst>
+          </a:custGeom>
+          <a:noFill/>
+          <a:ln w="9525" cap="flat" cmpd="sng">
+            <a:solidFill>
+              <a:srgbClr val="000000"/>
+            </a:solidFill>
+            <a:prstDash val="solid"/>
+            <a:round/>
+            <a:headEnd type="none" w="sm" len="sm"/>
+            <a:tailEnd type="none" w="sm" len="sm"/>
+          </a:ln>
+        </p:spPr>
+      </p:sp>
+      <p:sp>
+        <p:nvSpPr>
+          <p:cNvPr id="90" name="Google Shape;90;p3:notes"/>
+          <p:cNvSpPr txBox="1">
+            <a:spLocks noGrp="1"/>
+          </p:cNvSpPr>
+          <p:nvPr>
+            <p:ph type="body" idx="1"/>
+          </p:nvPr>
+        </p:nvSpPr>
+        <p:spPr>
+          <a:xfrm>
+            <a:off x="685800" y="4343400"/>
+            <a:ext cx="5486400" cy="4114800"/>
+          </a:xfrm>
+          <a:prstGeom prst="rect">
+            <a:avLst/>
+          </a:prstGeom>
+          <a:noFill/>
+          <a:ln>
+            <a:noFill/>
+          </a:ln>
+        </p:spPr>
+        <p:txBody>
+          <a:bodyPr spcFirstLastPara="1" wrap="square" lIns="91425" tIns="91425" rIns="91425" bIns="91425" anchor="t" anchorCtr="0">
+            <a:noAutofit/>
+          </a:bodyPr>
+          <a:lstStyle/>
+          <a:p>
+            <a:pPr marL="0" lvl="0" indent="0" algn="l" rtl="0">
+              <a:lnSpc>
+                <a:spcPct val="100000"/>
+              </a:lnSpc>
+              <a:spcBef>
+                <a:spcPts val="0"/>
+              </a:spcBef>
+              <a:spcAft>
+                <a:spcPts val="0"/>
+              </a:spcAft>
+              <a:buSzPts val="1100"/>
+              <a:buNone/>
+            </a:pPr>
+            <a:endParaRPr dirty="0"/>
+          </a:p>
+        </p:txBody>
+      </p:sp>
+    </p:spTree>
+    <p:extLst>
+      <p:ext uri="{BB962C8B-B14F-4D97-AF65-F5344CB8AC3E}">
+        <p14:creationId xmlns:p14="http://schemas.microsoft.com/office/powerpoint/2010/main" val="3125079081"/>
+      </p:ext>
+    </p:extLst>
+  </p:cSld>
+  <p:clrMapOvr>
+    <a:masterClrMapping/>
+  </p:clrMapOvr>
+</p:notes>
+</file>
+
+<file path=ppt/notesSlides/notesSlide5.xml><?xml version="1.0" encoding="utf-8"?>
+<p:notes xmlns:a="http://schemas.openxmlformats.org/drawingml/2006/main" xmlns:r="http://schemas.openxmlformats.org/officeDocument/2006/relationships" xmlns:p="http://schemas.openxmlformats.org/presentationml/2006/main" showMasterSp="0" showMasterPhAnim="0">
+  <p:cSld>
+    <p:spTree>
+      <p:nvGrpSpPr>
+        <p:cNvPr id="1" name="Shape 88"/>
+        <p:cNvGrpSpPr/>
+        <p:nvPr/>
+      </p:nvGrpSpPr>
+      <p:grpSpPr>
+        <a:xfrm>
+          <a:off x="0" y="0"/>
+          <a:ext cx="0" cy="0"/>
+          <a:chOff x="0" y="0"/>
+          <a:chExt cx="0" cy="0"/>
+        </a:xfrm>
+      </p:grpSpPr>
+      <p:sp>
+        <p:nvSpPr>
+          <p:cNvPr id="89" name="Google Shape;89;p3:notes"/>
+          <p:cNvSpPr>
+            <a:spLocks noGrp="1" noRot="1" noChangeAspect="1"/>
+          </p:cNvSpPr>
+          <p:nvPr>
+            <p:ph type="sldImg" idx="2"/>
+          </p:nvPr>
+        </p:nvSpPr>
+        <p:spPr>
+          <a:xfrm>
+            <a:off x="381000" y="685800"/>
+            <a:ext cx="6096000" cy="3429000"/>
+          </a:xfrm>
+          <a:custGeom>
+            <a:avLst/>
+            <a:gdLst/>
+            <a:ahLst/>
+            <a:cxnLst/>
+            <a:rect l="l" t="t" r="r" b="b"/>
+            <a:pathLst>
+              <a:path w="120000" h="120000" extrusionOk="0">
+                <a:moveTo>
+                  <a:pt x="0" y="0"/>
+                </a:moveTo>
+                <a:lnTo>
+                  <a:pt x="120000" y="0"/>
+                </a:lnTo>
+                <a:lnTo>
+                  <a:pt x="120000" y="120000"/>
+                </a:lnTo>
+                <a:lnTo>
+                  <a:pt x="0" y="120000"/>
+                </a:lnTo>
+                <a:close/>
+              </a:path>
+            </a:pathLst>
+          </a:custGeom>
+          <a:noFill/>
+          <a:ln w="9525" cap="flat" cmpd="sng">
+            <a:solidFill>
+              <a:srgbClr val="000000"/>
+            </a:solidFill>
+            <a:prstDash val="solid"/>
+            <a:round/>
+            <a:headEnd type="none" w="sm" len="sm"/>
+            <a:tailEnd type="none" w="sm" len="sm"/>
+          </a:ln>
+        </p:spPr>
+      </p:sp>
+      <p:sp>
+        <p:nvSpPr>
+          <p:cNvPr id="90" name="Google Shape;90;p3:notes"/>
+          <p:cNvSpPr txBox="1">
+            <a:spLocks noGrp="1"/>
+          </p:cNvSpPr>
+          <p:nvPr>
+            <p:ph type="body" idx="1"/>
+          </p:nvPr>
+        </p:nvSpPr>
+        <p:spPr>
+          <a:xfrm>
+            <a:off x="685800" y="4343400"/>
+            <a:ext cx="5486400" cy="4114800"/>
+          </a:xfrm>
+          <a:prstGeom prst="rect">
+            <a:avLst/>
+          </a:prstGeom>
+          <a:noFill/>
+          <a:ln>
+            <a:noFill/>
+          </a:ln>
+        </p:spPr>
+        <p:txBody>
+          <a:bodyPr spcFirstLastPara="1" wrap="square" lIns="91425" tIns="91425" rIns="91425" bIns="91425" anchor="t" anchorCtr="0">
+            <a:noAutofit/>
+          </a:bodyPr>
+          <a:lstStyle/>
+          <a:p>
+            <a:pPr marL="0" lvl="0" indent="0" algn="l" rtl="0">
+              <a:lnSpc>
+                <a:spcPct val="100000"/>
+              </a:lnSpc>
+              <a:spcBef>
+                <a:spcPts val="0"/>
+              </a:spcBef>
+              <a:spcAft>
+                <a:spcPts val="0"/>
+              </a:spcAft>
+              <a:buSzPts val="1100"/>
+              <a:buNone/>
+            </a:pPr>
+            <a:endParaRPr dirty="0"/>
+          </a:p>
+        </p:txBody>
+      </p:sp>
+    </p:spTree>
+    <p:extLst>
+      <p:ext uri="{BB962C8B-B14F-4D97-AF65-F5344CB8AC3E}">
+        <p14:creationId xmlns:p14="http://schemas.microsoft.com/office/powerpoint/2010/main" val="3711078716"/>
+      </p:ext>
+    </p:extLst>
+  </p:cSld>
+  <p:clrMapOvr>
+    <a:masterClrMapping/>
+  </p:clrMapOvr>
+</p:notes>
+</file>
+
+<file path=ppt/notesSlides/notesSlide6.xml><?xml version="1.0" encoding="utf-8"?>
+<p:notes xmlns:a="http://schemas.openxmlformats.org/drawingml/2006/main" xmlns:r="http://schemas.openxmlformats.org/officeDocument/2006/relationships" xmlns:p="http://schemas.openxmlformats.org/presentationml/2006/main" showMasterSp="0" showMasterPhAnim="0">
+  <p:cSld>
+    <p:spTree>
+      <p:nvGrpSpPr>
+        <p:cNvPr id="1" name="Shape 88"/>
+        <p:cNvGrpSpPr/>
+        <p:nvPr/>
+      </p:nvGrpSpPr>
+      <p:grpSpPr>
+        <a:xfrm>
+          <a:off x="0" y="0"/>
+          <a:ext cx="0" cy="0"/>
+          <a:chOff x="0" y="0"/>
+          <a:chExt cx="0" cy="0"/>
+        </a:xfrm>
+      </p:grpSpPr>
+      <p:sp>
+        <p:nvSpPr>
+          <p:cNvPr id="89" name="Google Shape;89;p3:notes"/>
+          <p:cNvSpPr>
+            <a:spLocks noGrp="1" noRot="1" noChangeAspect="1"/>
+          </p:cNvSpPr>
+          <p:nvPr>
+            <p:ph type="sldImg" idx="2"/>
+          </p:nvPr>
+        </p:nvSpPr>
+        <p:spPr>
+          <a:xfrm>
+            <a:off x="381000" y="685800"/>
+            <a:ext cx="6096000" cy="3429000"/>
+          </a:xfrm>
+          <a:custGeom>
+            <a:avLst/>
+            <a:gdLst/>
+            <a:ahLst/>
+            <a:cxnLst/>
+            <a:rect l="l" t="t" r="r" b="b"/>
+            <a:pathLst>
+              <a:path w="120000" h="120000" extrusionOk="0">
+                <a:moveTo>
+                  <a:pt x="0" y="0"/>
+                </a:moveTo>
+                <a:lnTo>
+                  <a:pt x="120000" y="0"/>
+                </a:lnTo>
+                <a:lnTo>
+                  <a:pt x="120000" y="120000"/>
+                </a:lnTo>
+                <a:lnTo>
+                  <a:pt x="0" y="120000"/>
+                </a:lnTo>
+                <a:close/>
+              </a:path>
+            </a:pathLst>
+          </a:custGeom>
+          <a:noFill/>
+          <a:ln w="9525" cap="flat" cmpd="sng">
+            <a:solidFill>
+              <a:srgbClr val="000000"/>
+            </a:solidFill>
+            <a:prstDash val="solid"/>
+            <a:round/>
+            <a:headEnd type="none" w="sm" len="sm"/>
+            <a:tailEnd type="none" w="sm" len="sm"/>
+          </a:ln>
+        </p:spPr>
+      </p:sp>
+      <p:sp>
+        <p:nvSpPr>
+          <p:cNvPr id="90" name="Google Shape;90;p3:notes"/>
+          <p:cNvSpPr txBox="1">
+            <a:spLocks noGrp="1"/>
+          </p:cNvSpPr>
+          <p:nvPr>
+            <p:ph type="body" idx="1"/>
+          </p:nvPr>
+        </p:nvSpPr>
+        <p:spPr>
+          <a:xfrm>
+            <a:off x="685800" y="4343400"/>
+            <a:ext cx="5486400" cy="4114800"/>
+          </a:xfrm>
+          <a:prstGeom prst="rect">
+            <a:avLst/>
+          </a:prstGeom>
+          <a:noFill/>
+          <a:ln>
+            <a:noFill/>
+          </a:ln>
+        </p:spPr>
+        <p:txBody>
+          <a:bodyPr spcFirstLastPara="1" wrap="square" lIns="91425" tIns="91425" rIns="91425" bIns="91425" anchor="t" anchorCtr="0">
+            <a:noAutofit/>
+          </a:bodyPr>
+          <a:lstStyle/>
+          <a:p>
+            <a:pPr marL="0" lvl="0" indent="0" algn="l" rtl="0">
+              <a:lnSpc>
+                <a:spcPct val="100000"/>
+              </a:lnSpc>
+              <a:spcBef>
+                <a:spcPts val="0"/>
+              </a:spcBef>
+              <a:spcAft>
+                <a:spcPts val="0"/>
+              </a:spcAft>
+              <a:buSzPts val="1100"/>
+              <a:buNone/>
+            </a:pPr>
+            <a:endParaRPr dirty="0"/>
+          </a:p>
+        </p:txBody>
+      </p:sp>
+    </p:spTree>
+    <p:extLst>
+      <p:ext uri="{BB962C8B-B14F-4D97-AF65-F5344CB8AC3E}">
+        <p14:creationId xmlns:p14="http://schemas.microsoft.com/office/powerpoint/2010/main" val="20685069"/>
+      </p:ext>
+    </p:extLst>
+  </p:cSld>
+  <p:clrMapOvr>
+    <a:masterClrMapping/>
+  </p:clrMapOvr>
+</p:notes>
+</file>
+
+<file path=ppt/notesSlides/notesSlide7.xml><?xml version="1.0" encoding="utf-8"?>
+<p:notes xmlns:a="http://schemas.openxmlformats.org/drawingml/2006/main" xmlns:r="http://schemas.openxmlformats.org/officeDocument/2006/relationships" xmlns:p="http://schemas.openxmlformats.org/presentationml/2006/main" showMasterSp="0" showMasterPhAnim="0">
+  <p:cSld>
+    <p:spTree>
+      <p:nvGrpSpPr>
+        <p:cNvPr id="1" name="Shape 88"/>
+        <p:cNvGrpSpPr/>
+        <p:nvPr/>
+      </p:nvGrpSpPr>
+      <p:grpSpPr>
+        <a:xfrm>
+          <a:off x="0" y="0"/>
+          <a:ext cx="0" cy="0"/>
+          <a:chOff x="0" y="0"/>
+          <a:chExt cx="0" cy="0"/>
+        </a:xfrm>
+      </p:grpSpPr>
+      <p:sp>
+        <p:nvSpPr>
+          <p:cNvPr id="89" name="Google Shape;89;p3:notes"/>
+          <p:cNvSpPr>
+            <a:spLocks noGrp="1" noRot="1" noChangeAspect="1"/>
+          </p:cNvSpPr>
+          <p:nvPr>
+            <p:ph type="sldImg" idx="2"/>
+          </p:nvPr>
+        </p:nvSpPr>
+        <p:spPr>
+          <a:xfrm>
+            <a:off x="381000" y="685800"/>
+            <a:ext cx="6096000" cy="3429000"/>
+          </a:xfrm>
+          <a:custGeom>
+            <a:avLst/>
+            <a:gdLst/>
+            <a:ahLst/>
+            <a:cxnLst/>
+            <a:rect l="l" t="t" r="r" b="b"/>
+            <a:pathLst>
+              <a:path w="120000" h="120000" extrusionOk="0">
+                <a:moveTo>
+                  <a:pt x="0" y="0"/>
+                </a:moveTo>
+                <a:lnTo>
+                  <a:pt x="120000" y="0"/>
+                </a:lnTo>
+                <a:lnTo>
+                  <a:pt x="120000" y="120000"/>
+                </a:lnTo>
+                <a:lnTo>
+                  <a:pt x="0" y="120000"/>
+                </a:lnTo>
+                <a:close/>
+              </a:path>
+            </a:pathLst>
+          </a:custGeom>
+          <a:noFill/>
+          <a:ln w="9525" cap="flat" cmpd="sng">
+            <a:solidFill>
+              <a:srgbClr val="000000"/>
+            </a:solidFill>
+            <a:prstDash val="solid"/>
+            <a:round/>
+            <a:headEnd type="none" w="sm" len="sm"/>
+            <a:tailEnd type="none" w="sm" len="sm"/>
+          </a:ln>
+        </p:spPr>
+      </p:sp>
+      <p:sp>
+        <p:nvSpPr>
+          <p:cNvPr id="90" name="Google Shape;90;p3:notes"/>
+          <p:cNvSpPr txBox="1">
+            <a:spLocks noGrp="1"/>
+          </p:cNvSpPr>
+          <p:nvPr>
+            <p:ph type="body" idx="1"/>
+          </p:nvPr>
+        </p:nvSpPr>
+        <p:spPr>
+          <a:xfrm>
+            <a:off x="685800" y="4343400"/>
+            <a:ext cx="5486400" cy="4114800"/>
+          </a:xfrm>
+          <a:prstGeom prst="rect">
+            <a:avLst/>
+          </a:prstGeom>
+          <a:noFill/>
+          <a:ln>
+            <a:noFill/>
+          </a:ln>
+        </p:spPr>
+        <p:txBody>
+          <a:bodyPr spcFirstLastPara="1" wrap="square" lIns="91425" tIns="91425" rIns="91425" bIns="91425" anchor="t" anchorCtr="0">
+            <a:noAutofit/>
+          </a:bodyPr>
+          <a:lstStyle/>
+          <a:p>
+            <a:pPr marL="0" lvl="0" indent="0" algn="l" rtl="0">
+              <a:lnSpc>
+                <a:spcPct val="100000"/>
+              </a:lnSpc>
+              <a:spcBef>
+                <a:spcPts val="0"/>
+              </a:spcBef>
+              <a:spcAft>
+                <a:spcPts val="0"/>
+              </a:spcAft>
+              <a:buSzPts val="1100"/>
+              <a:buNone/>
+            </a:pPr>
+            <a:endParaRPr dirty="0"/>
+          </a:p>
+        </p:txBody>
+      </p:sp>
+    </p:spTree>
+    <p:extLst>
+      <p:ext uri="{BB962C8B-B14F-4D97-AF65-F5344CB8AC3E}">
+        <p14:creationId xmlns:p14="http://schemas.microsoft.com/office/powerpoint/2010/main" val="698151680"/>
+      </p:ext>
+    </p:extLst>
+  </p:cSld>
+  <p:clrMapOvr>
+    <a:masterClrMapping/>
+  </p:clrMapOvr>
+</p:notes>
+</file>
+
+<file path=ppt/notesSlides/notesSlide8.xml><?xml version="1.0" encoding="utf-8"?>
 <p:notes xmlns:a="http://schemas.openxmlformats.org/drawingml/2006/main" xmlns:r="http://schemas.openxmlformats.org/officeDocument/2006/relationships" xmlns:p="http://schemas.openxmlformats.org/presentationml/2006/main" showMasterSp="0" showMasterPhAnim="0">
   <p:cSld>
     <p:spTree>
@@ -11197,7 +11718,7 @@
         </p:spPr>
         <p:txBody>
           <a:bodyPr spcFirstLastPara="1" wrap="square" lIns="91425" tIns="91425" rIns="91425" bIns="91425" anchor="t" anchorCtr="0">
-            <a:normAutofit lnSpcReduction="10000"/>
+            <a:normAutofit fontScale="92500"/>
           </a:bodyPr>
           <a:lstStyle/>
           <a:p>
@@ -11662,6 +12183,584 @@
 </file>
 
 <file path=ppt/slides/slide5.xml><?xml version="1.0" encoding="utf-8"?>
+<p:sld xmlns:a="http://schemas.openxmlformats.org/drawingml/2006/main" xmlns:r="http://schemas.openxmlformats.org/officeDocument/2006/relationships" xmlns:p="http://schemas.openxmlformats.org/presentationml/2006/main">
+  <p:cSld>
+    <p:spTree>
+      <p:nvGrpSpPr>
+        <p:cNvPr id="1" name="Shape 91"/>
+        <p:cNvGrpSpPr/>
+        <p:nvPr/>
+      </p:nvGrpSpPr>
+      <p:grpSpPr>
+        <a:xfrm>
+          <a:off x="0" y="0"/>
+          <a:ext cx="0" cy="0"/>
+          <a:chOff x="0" y="0"/>
+          <a:chExt cx="0" cy="0"/>
+        </a:xfrm>
+      </p:grpSpPr>
+      <p:sp>
+        <p:nvSpPr>
+          <p:cNvPr id="92" name="Google Shape;92;p22"/>
+          <p:cNvSpPr txBox="1">
+            <a:spLocks noGrp="1"/>
+          </p:cNvSpPr>
+          <p:nvPr>
+            <p:ph type="title"/>
+          </p:nvPr>
+        </p:nvSpPr>
+        <p:spPr>
+          <a:xfrm>
+            <a:off x="745874" y="230200"/>
+            <a:ext cx="4029326" cy="390689"/>
+          </a:xfrm>
+          <a:prstGeom prst="rect">
+            <a:avLst/>
+          </a:prstGeom>
+          <a:noFill/>
+          <a:ln>
+            <a:noFill/>
+          </a:ln>
+        </p:spPr>
+        <p:txBody>
+          <a:bodyPr spcFirstLastPara="1" wrap="square" lIns="91425" tIns="91425" rIns="91425" bIns="91425" anchor="t" anchorCtr="0">
+            <a:noAutofit/>
+          </a:bodyPr>
+          <a:lstStyle/>
+          <a:p>
+            <a:pPr marL="0" lvl="0" indent="0" algn="l" rtl="0">
+              <a:lnSpc>
+                <a:spcPct val="80000"/>
+              </a:lnSpc>
+              <a:spcBef>
+                <a:spcPts val="0"/>
+              </a:spcBef>
+              <a:spcAft>
+                <a:spcPts val="0"/>
+              </a:spcAft>
+              <a:buClr>
+                <a:srgbClr val="000000"/>
+              </a:buClr>
+              <a:buSzPts val="2400"/>
+              <a:buFont typeface="Arial"/>
+              <a:buNone/>
+            </a:pPr>
+            <a:r>
+              <a:rPr lang="pt-BR" sz="2000" b="1" dirty="0"/>
+              <a:t>DFS: Busca em Profundidade</a:t>
+            </a:r>
+            <a:endParaRPr sz="1900" dirty="0">
+              <a:solidFill>
+                <a:schemeClr val="dk2"/>
+              </a:solidFill>
+            </a:endParaRPr>
+          </a:p>
+          <a:p>
+            <a:pPr marL="0" lvl="0" indent="0" algn="l" rtl="0">
+              <a:lnSpc>
+                <a:spcPct val="75000"/>
+              </a:lnSpc>
+              <a:spcBef>
+                <a:spcPts val="0"/>
+              </a:spcBef>
+              <a:spcAft>
+                <a:spcPts val="0"/>
+              </a:spcAft>
+              <a:buSzPts val="3150"/>
+              <a:buNone/>
+            </a:pPr>
+            <a:endParaRPr sz="2450" dirty="0"/>
+          </a:p>
+        </p:txBody>
+      </p:sp>
+      <p:pic>
+        <p:nvPicPr>
+          <p:cNvPr id="5" name="Imagem 4">
+            <a:extLst>
+              <a:ext uri="{FF2B5EF4-FFF2-40B4-BE49-F238E27FC236}">
+                <a16:creationId xmlns:a16="http://schemas.microsoft.com/office/drawing/2014/main" id="{2A48E505-DA39-B318-CD6D-32C7D23B8F33}"/>
+              </a:ext>
+            </a:extLst>
+          </p:cNvPr>
+          <p:cNvPicPr>
+            <a:picLocks noChangeAspect="1"/>
+          </p:cNvPicPr>
+          <p:nvPr/>
+        </p:nvPicPr>
+        <p:blipFill>
+          <a:blip r:embed="rId3"/>
+          <a:stretch>
+            <a:fillRect/>
+          </a:stretch>
+        </p:blipFill>
+        <p:spPr>
+          <a:xfrm>
+            <a:off x="310444" y="1313038"/>
+            <a:ext cx="8523111" cy="2675467"/>
+          </a:xfrm>
+          <a:prstGeom prst="rect">
+            <a:avLst/>
+          </a:prstGeom>
+        </p:spPr>
+      </p:pic>
+    </p:spTree>
+    <p:extLst>
+      <p:ext uri="{BB962C8B-B14F-4D97-AF65-F5344CB8AC3E}">
+        <p14:creationId xmlns:p14="http://schemas.microsoft.com/office/powerpoint/2010/main" val="1482637592"/>
+      </p:ext>
+    </p:extLst>
+  </p:cSld>
+  <p:clrMapOvr>
+    <a:masterClrMapping/>
+  </p:clrMapOvr>
+</p:sld>
+</file>
+
+<file path=ppt/slides/slide6.xml><?xml version="1.0" encoding="utf-8"?>
+<p:sld xmlns:a="http://schemas.openxmlformats.org/drawingml/2006/main" xmlns:r="http://schemas.openxmlformats.org/officeDocument/2006/relationships" xmlns:p="http://schemas.openxmlformats.org/presentationml/2006/main">
+  <p:cSld>
+    <p:spTree>
+      <p:nvGrpSpPr>
+        <p:cNvPr id="1" name="Shape 91"/>
+        <p:cNvGrpSpPr/>
+        <p:nvPr/>
+      </p:nvGrpSpPr>
+      <p:grpSpPr>
+        <a:xfrm>
+          <a:off x="0" y="0"/>
+          <a:ext cx="0" cy="0"/>
+          <a:chOff x="0" y="0"/>
+          <a:chExt cx="0" cy="0"/>
+        </a:xfrm>
+      </p:grpSpPr>
+      <p:sp>
+        <p:nvSpPr>
+          <p:cNvPr id="92" name="Google Shape;92;p22"/>
+          <p:cNvSpPr txBox="1">
+            <a:spLocks noGrp="1"/>
+          </p:cNvSpPr>
+          <p:nvPr>
+            <p:ph type="title"/>
+          </p:nvPr>
+        </p:nvSpPr>
+        <p:spPr>
+          <a:xfrm>
+            <a:off x="745874" y="230200"/>
+            <a:ext cx="3069769" cy="390689"/>
+          </a:xfrm>
+          <a:prstGeom prst="rect">
+            <a:avLst/>
+          </a:prstGeom>
+          <a:noFill/>
+          <a:ln>
+            <a:noFill/>
+          </a:ln>
+        </p:spPr>
+        <p:txBody>
+          <a:bodyPr spcFirstLastPara="1" wrap="square" lIns="91425" tIns="91425" rIns="91425" bIns="91425" anchor="t" anchorCtr="0">
+            <a:noAutofit/>
+          </a:bodyPr>
+          <a:lstStyle/>
+          <a:p>
+            <a:pPr marL="0" lvl="0" indent="0" algn="l" rtl="0">
+              <a:lnSpc>
+                <a:spcPct val="80000"/>
+              </a:lnSpc>
+              <a:spcBef>
+                <a:spcPts val="0"/>
+              </a:spcBef>
+              <a:spcAft>
+                <a:spcPts val="0"/>
+              </a:spcAft>
+              <a:buClr>
+                <a:srgbClr val="000000"/>
+              </a:buClr>
+              <a:buSzPts val="2400"/>
+              <a:buFont typeface="Arial"/>
+              <a:buNone/>
+            </a:pPr>
+            <a:r>
+              <a:rPr lang="pt-BR" sz="2000" b="1" dirty="0"/>
+              <a:t>BFS: Busca em Largura</a:t>
+            </a:r>
+            <a:endParaRPr sz="1900" dirty="0">
+              <a:solidFill>
+                <a:schemeClr val="dk2"/>
+              </a:solidFill>
+            </a:endParaRPr>
+          </a:p>
+          <a:p>
+            <a:pPr marL="0" lvl="0" indent="0" algn="l" rtl="0">
+              <a:lnSpc>
+                <a:spcPct val="75000"/>
+              </a:lnSpc>
+              <a:spcBef>
+                <a:spcPts val="0"/>
+              </a:spcBef>
+              <a:spcAft>
+                <a:spcPts val="0"/>
+              </a:spcAft>
+              <a:buSzPts val="3150"/>
+              <a:buNone/>
+            </a:pPr>
+            <a:endParaRPr sz="2450" dirty="0"/>
+          </a:p>
+        </p:txBody>
+      </p:sp>
+      <p:pic>
+        <p:nvPicPr>
+          <p:cNvPr id="5" name="Imagem 4">
+            <a:extLst>
+              <a:ext uri="{FF2B5EF4-FFF2-40B4-BE49-F238E27FC236}">
+                <a16:creationId xmlns:a16="http://schemas.microsoft.com/office/drawing/2014/main" id="{833B2D8E-2158-68A8-3A60-1C61EF0EF1DC}"/>
+              </a:ext>
+            </a:extLst>
+          </p:cNvPr>
+          <p:cNvPicPr>
+            <a:picLocks noChangeAspect="1"/>
+          </p:cNvPicPr>
+          <p:nvPr/>
+        </p:nvPicPr>
+        <p:blipFill>
+          <a:blip r:embed="rId3"/>
+          <a:stretch>
+            <a:fillRect/>
+          </a:stretch>
+        </p:blipFill>
+        <p:spPr>
+          <a:xfrm>
+            <a:off x="700717" y="1034222"/>
+            <a:ext cx="8071556" cy="3546231"/>
+          </a:xfrm>
+          <a:prstGeom prst="rect">
+            <a:avLst/>
+          </a:prstGeom>
+        </p:spPr>
+      </p:pic>
+    </p:spTree>
+    <p:extLst>
+      <p:ext uri="{BB962C8B-B14F-4D97-AF65-F5344CB8AC3E}">
+        <p14:creationId xmlns:p14="http://schemas.microsoft.com/office/powerpoint/2010/main" val="2238209613"/>
+      </p:ext>
+    </p:extLst>
+  </p:cSld>
+  <p:clrMapOvr>
+    <a:masterClrMapping/>
+  </p:clrMapOvr>
+</p:sld>
+</file>
+
+<file path=ppt/slides/slide7.xml><?xml version="1.0" encoding="utf-8"?>
+<p:sld xmlns:a="http://schemas.openxmlformats.org/drawingml/2006/main" xmlns:r="http://schemas.openxmlformats.org/officeDocument/2006/relationships" xmlns:p="http://schemas.openxmlformats.org/presentationml/2006/main">
+  <p:cSld>
+    <p:spTree>
+      <p:nvGrpSpPr>
+        <p:cNvPr id="1" name="Shape 91"/>
+        <p:cNvGrpSpPr/>
+        <p:nvPr/>
+      </p:nvGrpSpPr>
+      <p:grpSpPr>
+        <a:xfrm>
+          <a:off x="0" y="0"/>
+          <a:ext cx="0" cy="0"/>
+          <a:chOff x="0" y="0"/>
+          <a:chExt cx="0" cy="0"/>
+        </a:xfrm>
+      </p:grpSpPr>
+      <p:sp>
+        <p:nvSpPr>
+          <p:cNvPr id="92" name="Google Shape;92;p22"/>
+          <p:cNvSpPr txBox="1">
+            <a:spLocks noGrp="1"/>
+          </p:cNvSpPr>
+          <p:nvPr>
+            <p:ph type="title"/>
+          </p:nvPr>
+        </p:nvSpPr>
+        <p:spPr>
+          <a:xfrm>
+            <a:off x="745874" y="230200"/>
+            <a:ext cx="4277682" cy="390689"/>
+          </a:xfrm>
+          <a:prstGeom prst="rect">
+            <a:avLst/>
+          </a:prstGeom>
+          <a:noFill/>
+          <a:ln>
+            <a:noFill/>
+          </a:ln>
+        </p:spPr>
+        <p:txBody>
+          <a:bodyPr spcFirstLastPara="1" wrap="square" lIns="91425" tIns="91425" rIns="91425" bIns="91425" anchor="t" anchorCtr="0">
+            <a:noAutofit/>
+          </a:bodyPr>
+          <a:lstStyle/>
+          <a:p>
+            <a:pPr marL="0" lvl="0" indent="0" algn="l" rtl="0">
+              <a:lnSpc>
+                <a:spcPct val="75000"/>
+              </a:lnSpc>
+              <a:spcBef>
+                <a:spcPts val="0"/>
+              </a:spcBef>
+              <a:spcAft>
+                <a:spcPts val="0"/>
+              </a:spcAft>
+              <a:buSzPts val="3150"/>
+              <a:buNone/>
+            </a:pPr>
+            <a:r>
+              <a:rPr lang="pt-BR" sz="2450" dirty="0"/>
+              <a:t>DFS vs. BFS no Labirinto</a:t>
+            </a:r>
+            <a:endParaRPr sz="2450" dirty="0"/>
+          </a:p>
+        </p:txBody>
+      </p:sp>
+      <p:pic>
+        <p:nvPicPr>
+          <p:cNvPr id="6" name="Imagem 5">
+            <a:extLst>
+              <a:ext uri="{FF2B5EF4-FFF2-40B4-BE49-F238E27FC236}">
+                <a16:creationId xmlns:a16="http://schemas.microsoft.com/office/drawing/2014/main" id="{7FFF65B2-A1EE-7026-49F9-8A9AEA1827A8}"/>
+              </a:ext>
+            </a:extLst>
+          </p:cNvPr>
+          <p:cNvPicPr>
+            <a:picLocks noChangeAspect="1"/>
+          </p:cNvPicPr>
+          <p:nvPr/>
+        </p:nvPicPr>
+        <p:blipFill>
+          <a:blip r:embed="rId3"/>
+          <a:stretch>
+            <a:fillRect/>
+          </a:stretch>
+        </p:blipFill>
+        <p:spPr>
+          <a:xfrm>
+            <a:off x="1675173" y="739378"/>
+            <a:ext cx="5793653" cy="4173922"/>
+          </a:xfrm>
+          <a:prstGeom prst="rect">
+            <a:avLst/>
+          </a:prstGeom>
+        </p:spPr>
+      </p:pic>
+      <p:sp>
+        <p:nvSpPr>
+          <p:cNvPr id="2" name="AutoShape 2">
+            <a:extLst>
+              <a:ext uri="{FF2B5EF4-FFF2-40B4-BE49-F238E27FC236}">
+                <a16:creationId xmlns:a16="http://schemas.microsoft.com/office/drawing/2014/main" id="{A0557725-CCF3-0388-59DB-484FF7B533CF}"/>
+              </a:ext>
+            </a:extLst>
+          </p:cNvPr>
+          <p:cNvSpPr>
+            <a:spLocks noChangeAspect="1" noChangeArrowheads="1"/>
+          </p:cNvSpPr>
+          <p:nvPr/>
+        </p:nvSpPr>
+        <p:spPr bwMode="auto">
+          <a:xfrm>
+            <a:off x="4419600" y="2419350"/>
+            <a:ext cx="304800" cy="304800"/>
+          </a:xfrm>
+          <a:prstGeom prst="rect">
+            <a:avLst/>
+          </a:prstGeom>
+          <a:noFill/>
+          <a:extLst>
+            <a:ext uri="{909E8E84-426E-40DD-AFC4-6F175D3DCCD1}">
+              <a14:hiddenFill xmlns:a14="http://schemas.microsoft.com/office/drawing/2010/main">
+                <a:solidFill>
+                  <a:srgbClr val="FFFFFF"/>
+                </a:solidFill>
+              </a14:hiddenFill>
+            </a:ext>
+          </a:extLst>
+        </p:spPr>
+        <p:txBody>
+          <a:bodyPr vert="horz" wrap="square" lIns="91440" tIns="45720" rIns="91440" bIns="45720" numCol="1" anchor="t" anchorCtr="0" compatLnSpc="1">
+            <a:prstTxWarp prst="textNoShape">
+              <a:avLst/>
+            </a:prstTxWarp>
+          </a:bodyPr>
+          <a:lstStyle/>
+          <a:p>
+            <a:endParaRPr lang="pt-BR"/>
+          </a:p>
+        </p:txBody>
+      </p:sp>
+    </p:spTree>
+    <p:extLst>
+      <p:ext uri="{BB962C8B-B14F-4D97-AF65-F5344CB8AC3E}">
+        <p14:creationId xmlns:p14="http://schemas.microsoft.com/office/powerpoint/2010/main" val="1377394252"/>
+      </p:ext>
+    </p:extLst>
+  </p:cSld>
+  <p:clrMapOvr>
+    <a:masterClrMapping/>
+  </p:clrMapOvr>
+</p:sld>
+</file>
+
+<file path=ppt/slides/slide8.xml><?xml version="1.0" encoding="utf-8"?>
+<p:sld xmlns:a="http://schemas.openxmlformats.org/drawingml/2006/main" xmlns:r="http://schemas.openxmlformats.org/officeDocument/2006/relationships" xmlns:p="http://schemas.openxmlformats.org/presentationml/2006/main">
+  <p:cSld>
+    <p:spTree>
+      <p:nvGrpSpPr>
+        <p:cNvPr id="1" name="Shape 91"/>
+        <p:cNvGrpSpPr/>
+        <p:nvPr/>
+      </p:nvGrpSpPr>
+      <p:grpSpPr>
+        <a:xfrm>
+          <a:off x="0" y="0"/>
+          <a:ext cx="0" cy="0"/>
+          <a:chOff x="0" y="0"/>
+          <a:chExt cx="0" cy="0"/>
+        </a:xfrm>
+      </p:grpSpPr>
+      <p:sp>
+        <p:nvSpPr>
+          <p:cNvPr id="92" name="Google Shape;92;p22"/>
+          <p:cNvSpPr txBox="1">
+            <a:spLocks noGrp="1"/>
+          </p:cNvSpPr>
+          <p:nvPr>
+            <p:ph type="title"/>
+          </p:nvPr>
+        </p:nvSpPr>
+        <p:spPr>
+          <a:xfrm>
+            <a:off x="745874" y="230200"/>
+            <a:ext cx="4277682" cy="390689"/>
+          </a:xfrm>
+          <a:prstGeom prst="rect">
+            <a:avLst/>
+          </a:prstGeom>
+          <a:noFill/>
+          <a:ln>
+            <a:noFill/>
+          </a:ln>
+        </p:spPr>
+        <p:txBody>
+          <a:bodyPr spcFirstLastPara="1" wrap="square" lIns="91425" tIns="91425" rIns="91425" bIns="91425" anchor="t" anchorCtr="0">
+            <a:noAutofit/>
+          </a:bodyPr>
+          <a:lstStyle/>
+          <a:p>
+            <a:pPr marL="0" lvl="0" indent="0" algn="l" rtl="0">
+              <a:lnSpc>
+                <a:spcPct val="75000"/>
+              </a:lnSpc>
+              <a:spcBef>
+                <a:spcPts val="0"/>
+              </a:spcBef>
+              <a:spcAft>
+                <a:spcPts val="0"/>
+              </a:spcAft>
+              <a:buSzPts val="3150"/>
+              <a:buNone/>
+            </a:pPr>
+            <a:r>
+              <a:rPr lang="pt-BR" sz="2450" dirty="0"/>
+              <a:t>Validação</a:t>
+            </a:r>
+            <a:endParaRPr sz="2450" dirty="0"/>
+          </a:p>
+        </p:txBody>
+      </p:sp>
+      <p:sp>
+        <p:nvSpPr>
+          <p:cNvPr id="2" name="AutoShape 2">
+            <a:extLst>
+              <a:ext uri="{FF2B5EF4-FFF2-40B4-BE49-F238E27FC236}">
+                <a16:creationId xmlns:a16="http://schemas.microsoft.com/office/drawing/2014/main" id="{A0557725-CCF3-0388-59DB-484FF7B533CF}"/>
+              </a:ext>
+            </a:extLst>
+          </p:cNvPr>
+          <p:cNvSpPr>
+            <a:spLocks noChangeAspect="1" noChangeArrowheads="1"/>
+          </p:cNvSpPr>
+          <p:nvPr/>
+        </p:nvSpPr>
+        <p:spPr bwMode="auto">
+          <a:xfrm>
+            <a:off x="4419600" y="2419350"/>
+            <a:ext cx="304800" cy="304800"/>
+          </a:xfrm>
+          <a:prstGeom prst="rect">
+            <a:avLst/>
+          </a:prstGeom>
+          <a:noFill/>
+          <a:extLst>
+            <a:ext uri="{909E8E84-426E-40DD-AFC4-6F175D3DCCD1}">
+              <a14:hiddenFill xmlns:a14="http://schemas.microsoft.com/office/drawing/2010/main">
+                <a:solidFill>
+                  <a:srgbClr val="FFFFFF"/>
+                </a:solidFill>
+              </a14:hiddenFill>
+            </a:ext>
+          </a:extLst>
+        </p:spPr>
+        <p:txBody>
+          <a:bodyPr vert="horz" wrap="square" lIns="91440" tIns="45720" rIns="91440" bIns="45720" numCol="1" anchor="t" anchorCtr="0" compatLnSpc="1">
+            <a:prstTxWarp prst="textNoShape">
+              <a:avLst/>
+            </a:prstTxWarp>
+          </a:bodyPr>
+          <a:lstStyle/>
+          <a:p>
+            <a:endParaRPr lang="pt-BR"/>
+          </a:p>
+        </p:txBody>
+      </p:sp>
+      <p:pic>
+        <p:nvPicPr>
+          <p:cNvPr id="4" name="Imagem 3">
+            <a:extLst>
+              <a:ext uri="{FF2B5EF4-FFF2-40B4-BE49-F238E27FC236}">
+                <a16:creationId xmlns:a16="http://schemas.microsoft.com/office/drawing/2014/main" id="{AD81C47F-245E-C9E4-0776-0BB10F3B9161}"/>
+              </a:ext>
+            </a:extLst>
+          </p:cNvPr>
+          <p:cNvPicPr>
+            <a:picLocks noChangeAspect="1"/>
+          </p:cNvPicPr>
+          <p:nvPr/>
+        </p:nvPicPr>
+        <p:blipFill>
+          <a:blip r:embed="rId3"/>
+          <a:stretch>
+            <a:fillRect/>
+          </a:stretch>
+        </p:blipFill>
+        <p:spPr>
+          <a:xfrm>
+            <a:off x="745874" y="623326"/>
+            <a:ext cx="6492361" cy="4289974"/>
+          </a:xfrm>
+          <a:prstGeom prst="rect">
+            <a:avLst/>
+          </a:prstGeom>
+        </p:spPr>
+      </p:pic>
+    </p:spTree>
+    <p:extLst>
+      <p:ext uri="{BB962C8B-B14F-4D97-AF65-F5344CB8AC3E}">
+        <p14:creationId xmlns:p14="http://schemas.microsoft.com/office/powerpoint/2010/main" val="3244304480"/>
+      </p:ext>
+    </p:extLst>
+  </p:cSld>
+  <p:clrMapOvr>
+    <a:masterClrMapping/>
+  </p:clrMapOvr>
+</p:sld>
+</file>
+
+<file path=ppt/slides/slide9.xml><?xml version="1.0" encoding="utf-8"?>
 <p:sld xmlns:a="http://schemas.openxmlformats.org/drawingml/2006/main" xmlns:r="http://schemas.openxmlformats.org/officeDocument/2006/relationships" xmlns:p="http://schemas.openxmlformats.org/presentationml/2006/main">
   <p:cSld>
     <p:spTree>

</xml_diff>

<commit_message>
alteração dos nomes no slide
</commit_message>
<xml_diff>
--- a/Slide_labirinto.pptx
+++ b/Slide_labirinto.pptx
@@ -258,6 +258,11 @@
       </a:defRPr>
     </a:lvl9pPr>
   </p:defaultTextStyle>
+  <p:extLst>
+    <p:ext uri="{EFAFB233-063F-42B5-8137-9DF3F51BA10A}">
+      <p15:sldGuideLst xmlns:p15="http://schemas.microsoft.com/office/powerpoint/2012/main"/>
+    </p:ext>
+  </p:extLst>
 </p:presentation>
 </file>
 
@@ -997,7 +1002,7 @@
         </p:nvSpPr>
         <p:spPr>
           <a:xfrm>
-            <a:off x="381300" y="685800"/>
+            <a:off x="381000" y="685800"/>
             <a:ext cx="6096000" cy="3429000"/>
           </a:xfrm>
           <a:custGeom>
@@ -11452,10 +11457,10 @@
               <a:buNone/>
             </a:pPr>
             <a:r>
-              <a:rPr lang="pt-BR" b="1"/>
+              <a:rPr lang="pt-BR" b="1" dirty="0"/>
               <a:t>Título</a:t>
             </a:r>
-            <a:endParaRPr b="1"/>
+            <a:endParaRPr b="1" dirty="0"/>
           </a:p>
         </p:txBody>
       </p:sp>
@@ -11484,7 +11489,7 @@
         </p:spPr>
         <p:txBody>
           <a:bodyPr spcFirstLastPara="1" wrap="square" lIns="91425" tIns="91425" rIns="91425" bIns="91425" anchor="t" anchorCtr="0">
-            <a:normAutofit/>
+            <a:normAutofit lnSpcReduction="10000"/>
           </a:bodyPr>
           <a:lstStyle/>
           <a:p>
@@ -11502,10 +11507,10 @@
               <a:buNone/>
             </a:pPr>
             <a:r>
-              <a:rPr lang="pt-BR" sz="2000"/>
+              <a:rPr lang="pt-BR" sz="2000" dirty="0"/>
               <a:t>Subtítulo</a:t>
             </a:r>
-            <a:endParaRPr sz="2000"/>
+            <a:endParaRPr sz="2000" dirty="0"/>
           </a:p>
           <a:p>
             <a:pPr marL="0" lvl="0" indent="0" algn="l" rtl="0">
@@ -11521,7 +11526,7 @@
               <a:buSzPts val="2400"/>
               <a:buNone/>
             </a:pPr>
-            <a:endParaRPr sz="2000"/>
+            <a:endParaRPr sz="2000" dirty="0"/>
           </a:p>
           <a:p>
             <a:pPr marL="0" marR="146269" lvl="0" indent="0" algn="r" rtl="0">
@@ -11538,10 +11543,9 @@
               <a:buNone/>
             </a:pPr>
             <a:r>
-              <a:rPr lang="pt-BR" sz="1400" b="1" i="1"/>
-              <a:t>Alunos: Nomes - Matrícula</a:t>
+              <a:rPr lang="pt-BR" sz="1400" b="1" i="1" dirty="0"/>
+              <a:t>Alunos: Guilherme – 2116188</a:t>
             </a:r>
-            <a:endParaRPr sz="1400" b="1" i="1"/>
           </a:p>
           <a:p>
             <a:pPr marL="0" marR="146269" lvl="0" indent="0" algn="r" rtl="0">
@@ -11558,10 +11562,9 @@
               <a:buNone/>
             </a:pPr>
             <a:r>
-              <a:rPr lang="pt-BR" sz="1400" i="1"/>
-              <a:t>Orientador: Prof. Me. Ricardo Carubbi</a:t>
+              <a:rPr lang="pt-BR" sz="1400" b="1" i="1" dirty="0"/>
+              <a:t>Juan – 2417213</a:t>
             </a:r>
-            <a:endParaRPr sz="1400" i="1"/>
           </a:p>
           <a:p>
             <a:pPr marL="0" marR="146269" lvl="0" indent="0" algn="r" rtl="0">
@@ -11578,10 +11581,53 @@
               <a:buNone/>
             </a:pPr>
             <a:r>
-              <a:rPr lang="pt-BR" sz="1400" i="1"/>
+              <a:rPr lang="pt-BR" sz="1400" b="1" i="1" dirty="0"/>
+              <a:t>Daniel - 2310285</a:t>
+            </a:r>
+          </a:p>
+          <a:p>
+            <a:pPr marL="0" marR="146269" lvl="0" indent="0" algn="r" rtl="0">
+              <a:lnSpc>
+                <a:spcPct val="80000"/>
+              </a:lnSpc>
+              <a:spcBef>
+                <a:spcPts val="0"/>
+              </a:spcBef>
+              <a:spcAft>
+                <a:spcPts val="0"/>
+              </a:spcAft>
+              <a:buSzPts val="2400"/>
+              <a:buNone/>
+            </a:pPr>
+            <a:r>
+              <a:rPr lang="pt-BR" sz="1400" i="1" dirty="0"/>
+              <a:t>Orientador: Prof. Me. Ricardo </a:t>
+            </a:r>
+            <a:r>
+              <a:rPr lang="pt-BR" sz="1400" i="1" dirty="0" err="1"/>
+              <a:t>Carubbi</a:t>
+            </a:r>
+            <a:endParaRPr sz="1400" i="1" dirty="0"/>
+          </a:p>
+          <a:p>
+            <a:pPr marL="0" marR="146269" lvl="0" indent="0" algn="r" rtl="0">
+              <a:lnSpc>
+                <a:spcPct val="80000"/>
+              </a:lnSpc>
+              <a:spcBef>
+                <a:spcPts val="0"/>
+              </a:spcBef>
+              <a:spcAft>
+                <a:spcPts val="0"/>
+              </a:spcAft>
+              <a:buSzPts val="2400"/>
+              <a:buNone/>
+            </a:pPr>
+            <a:r>
+              <a:rPr lang="pt-BR" sz="1400" i="1" dirty="0"/>
               <a:t>Disciplina: Métodos Quantitativos</a:t>
             </a:r>
-            <a:endParaRPr sz="1400" i="1"/>
+            <a:endParaRPr sz="1400" i="1" dirty="0"/>
           </a:p>
           <a:p>
             <a:pPr marL="0" marR="146268" lvl="0" indent="0" algn="r" rtl="0">
@@ -11598,10 +11644,10 @@
               <a:buNone/>
             </a:pPr>
             <a:r>
-              <a:rPr lang="pt-BR" sz="1400" i="1"/>
+              <a:rPr lang="pt-BR" sz="1400" i="1" dirty="0"/>
               <a:t>Centro de Ciências Tecnológicas - CCT</a:t>
             </a:r>
-            <a:endParaRPr sz="1400" i="1"/>
+            <a:endParaRPr sz="1400" i="1" dirty="0"/>
           </a:p>
           <a:p>
             <a:pPr marL="0" marR="146269" lvl="0" indent="0" algn="r" rtl="0">
@@ -11618,10 +11664,10 @@
               <a:buNone/>
             </a:pPr>
             <a:r>
-              <a:rPr lang="pt-BR" sz="1400" i="1"/>
+              <a:rPr lang="pt-BR" sz="1400" i="1" dirty="0"/>
               <a:t>Universidade de Fortaleza - UNIFOR</a:t>
             </a:r>
-            <a:endParaRPr sz="1400" i="1"/>
+            <a:endParaRPr sz="1400" i="1" dirty="0"/>
           </a:p>
         </p:txBody>
       </p:sp>
@@ -11876,6 +11922,36 @@
           </a:p>
         </p:txBody>
       </p:sp>
+      <p:pic>
+        <p:nvPicPr>
+          <p:cNvPr id="3" name="Imagem 2">
+            <a:extLst>
+              <a:ext uri="{FF2B5EF4-FFF2-40B4-BE49-F238E27FC236}">
+                <a16:creationId xmlns:a16="http://schemas.microsoft.com/office/drawing/2014/main" id="{C58019E6-5EF5-2597-CB6B-027AD7A09265}"/>
+              </a:ext>
+            </a:extLst>
+          </p:cNvPr>
+          <p:cNvPicPr>
+            <a:picLocks noChangeAspect="1"/>
+          </p:cNvPicPr>
+          <p:nvPr/>
+        </p:nvPicPr>
+        <p:blipFill>
+          <a:blip r:embed="rId3"/>
+          <a:stretch>
+            <a:fillRect/>
+          </a:stretch>
+        </p:blipFill>
+        <p:spPr>
+          <a:xfrm>
+            <a:off x="5945592" y="230200"/>
+            <a:ext cx="1790950" cy="1762371"/>
+          </a:xfrm>
+          <a:prstGeom prst="rect">
+            <a:avLst/>
+          </a:prstGeom>
+        </p:spPr>
+      </p:pic>
     </p:spTree>
   </p:cSld>
   <p:clrMapOvr>

</xml_diff>